<commit_message>
chore(gs-weekly): 8월 마지막주 → 9월 뷰 전환
WEEK_VIEW_OVERRIDE=true + rm_fcst_view_override.txt=2026-09. 당월 9월 RM FCST=67,916 /
누계 1~9월=673,145. 정적 PPT/xlsx 9월(GS otb_data 9월 객실+소사업). 롤오버 시 원복.

Co-Authored-By: Claude Opus 4.8 (1M context) <noreply@anthropic.com>
</commit_message>
<xml_diff>
--- a/data/세일즈마케팅_예상매출현황.pptx
+++ b/data/세일즈마케팅_예상매출현황.pptx
@@ -4058,7 +4058,7 @@
                           <a:latin typeface="대명체 보통" panose="020B0600000101010101" pitchFamily="50" charset="-127"/>
                           <a:ea typeface="대명체 보통" panose="020B0600000101010101" pitchFamily="50" charset="-127"/>
                         </a:rPr>
-                        <a:t>당월 예상실적 (08.01~08.31)</a:t>
+                        <a:t>당월 예상실적 (09.01~09.30)</a:t>
                       </a:r>
                       <a:endParaRPr lang="en-US" altLang="ko-KR" sz="800" b="1" i="0" u="none" strike="noStrike" dirty="0">
                         <a:ln>
@@ -4310,7 +4310,7 @@
                           <a:latin typeface="대명체 보통" panose="020B0600000101010101" pitchFamily="50" charset="-127"/>
                           <a:ea typeface="대명체 보통" panose="020B0600000101010101" pitchFamily="50" charset="-127"/>
                         </a:rPr>
-                        <a:t>누계 실적 (01.01~08.31)</a:t>
+                        <a:t>누계 실적 (01.01~09.30)</a:t>
                       </a:r>
                       <a:endParaRPr lang="en-US" altLang="ko-KR" sz="800" b="1" i="0" u="none" strike="noStrike" dirty="0">
                         <a:ln>
@@ -12630,7 +12630,7 @@
                           <a:ea typeface="대명체 보통" panose="020B0600000101010101" pitchFamily="50" charset="-127"/>
                           <a:cs typeface="+mn-cs"/>
                         </a:rPr>
-                        <a:t>23,859</a:t>
+                        <a:t>14,106</a:t>
                       </a:r>
                     </a:p>
                   </a:txBody>
@@ -12756,7 +12756,7 @@
                           <a:ea typeface="대명체 보통" panose="020B0600000101010101" pitchFamily="50" charset="-127"/>
                           <a:cs typeface="+mn-cs"/>
                         </a:rPr>
-                        <a:t>25,701</a:t>
+                        <a:t>15,037</a:t>
                       </a:r>
                     </a:p>
                   </a:txBody>
@@ -12882,7 +12882,7 @@
                           <a:ea typeface="대명체 보통" panose="020B0600000101010101" pitchFamily="50" charset="-127"/>
                           <a:cs typeface="+mn-cs"/>
                         </a:rPr>
-                        <a:t>1,842</a:t>
+                        <a:t>931</a:t>
                       </a:r>
                     </a:p>
                   </a:txBody>
@@ -12949,7 +12949,7 @@
                           <a:ea typeface="대명체 보통" panose="020B0600000101010101" pitchFamily="50" charset="-127"/>
                           <a:cs typeface="+mn-cs"/>
                         </a:rPr>
-                        <a:t>108%</a:t>
+                        <a:t>107%</a:t>
                       </a:r>
                     </a:p>
                   </a:txBody>
@@ -13016,7 +13016,7 @@
                           <a:ea typeface="대명체 보통" panose="020B0600000101010101" pitchFamily="50" charset="-127"/>
                           <a:cs typeface="+mn-cs"/>
                         </a:rPr>
-                        <a:t>20,965</a:t>
+                        <a:t>5,980</a:t>
                       </a:r>
                     </a:p>
                   </a:txBody>
@@ -13142,7 +13142,7 @@
                           <a:ea typeface="대명체 보통" panose="020B0600000101010101" pitchFamily="50" charset="-127"/>
                           <a:cs typeface="+mn-cs"/>
                         </a:rPr>
-                        <a:t>4,735</a:t>
+                        <a:t>9,057</a:t>
                       </a:r>
                     </a:p>
                   </a:txBody>
@@ -13209,7 +13209,7 @@
                           <a:ea typeface="대명체 보통" panose="020B0600000101010101" pitchFamily="50" charset="-127"/>
                           <a:cs typeface="+mn-cs"/>
                         </a:rPr>
-                        <a:t>23%</a:t>
+                        <a:t>151%</a:t>
                       </a:r>
                     </a:p>
                   </a:txBody>
@@ -13328,7 +13328,7 @@
                           <a:ea typeface="대명체 보통" panose="020B0600000101010101" pitchFamily="50" charset="-127"/>
                           <a:cs typeface="+mn-cs"/>
                         </a:rPr>
-                        <a:t>124,921</a:t>
+                        <a:t>139,028</a:t>
                       </a:r>
                     </a:p>
                   </a:txBody>
@@ -13450,7 +13450,7 @@
                           <a:ea typeface="대명체 보통" panose="020B0600000101010101" pitchFamily="50" charset="-127"/>
                           <a:cs typeface="+mn-cs"/>
                         </a:rPr>
-                        <a:t>142,171</a:t>
+                        <a:t>157,207</a:t>
                       </a:r>
                     </a:p>
                   </a:txBody>
@@ -13576,7 +13576,7 @@
                           <a:ea typeface="대명체 보통" panose="020B0600000101010101" pitchFamily="50" charset="-127"/>
                           <a:cs typeface="+mn-cs"/>
                         </a:rPr>
-                        <a:t>17,249</a:t>
+                        <a:t>18,179</a:t>
                       </a:r>
                     </a:p>
                   </a:txBody>
@@ -13643,7 +13643,7 @@
                           <a:ea typeface="대명체 보통" panose="020B0600000101010101" pitchFamily="50" charset="-127"/>
                           <a:cs typeface="+mn-cs"/>
                         </a:rPr>
-                        <a:t>114%</a:t>
+                        <a:t>113%</a:t>
                       </a:r>
                     </a:p>
                   </a:txBody>
@@ -13710,7 +13710,7 @@
                           <a:ea typeface="대명체 보통" panose="020B0600000101010101" pitchFamily="50" charset="-127"/>
                           <a:cs typeface="+mn-cs"/>
                         </a:rPr>
-                        <a:t>102,130</a:t>
+                        <a:t>108,110</a:t>
                       </a:r>
                     </a:p>
                   </a:txBody>
@@ -13836,7 +13836,7 @@
                           <a:ea typeface="대명체 보통" panose="020B0600000101010101" pitchFamily="50" charset="-127"/>
                           <a:cs typeface="+mn-cs"/>
                         </a:rPr>
-                        <a:t>40,041</a:t>
+                        <a:t>49,097</a:t>
                       </a:r>
                     </a:p>
                   </a:txBody>
@@ -13903,7 +13903,7 @@
                           <a:ea typeface="대명체 보통" panose="020B0600000101010101" pitchFamily="50" charset="-127"/>
                           <a:cs typeface="+mn-cs"/>
                         </a:rPr>
-                        <a:t>39%</a:t>
+                        <a:t>45%</a:t>
                       </a:r>
                     </a:p>
                   </a:txBody>
@@ -14119,7 +14119,7 @@
                           <a:ea typeface="대명체 보통" panose="020B0600000101010101" pitchFamily="50" charset="-127"/>
                           <a:cs typeface="+mn-cs"/>
                         </a:rPr>
-                        <a:t>14,604</a:t>
+                        <a:t>8,023</a:t>
                       </a:r>
                     </a:p>
                   </a:txBody>
@@ -14237,7 +14237,7 @@
                           <a:ea typeface="대명체 보통" panose="020B0600000101010101" pitchFamily="50" charset="-127"/>
                           <a:cs typeface="+mn-cs"/>
                         </a:rPr>
-                        <a:t>15,332</a:t>
+                        <a:t>8,172</a:t>
                       </a:r>
                     </a:p>
                   </a:txBody>
@@ -14355,7 +14355,7 @@
                           <a:ea typeface="대명체 보통" panose="020B0600000101010101" pitchFamily="50" charset="-127"/>
                           <a:cs typeface="+mn-cs"/>
                         </a:rPr>
-                        <a:t>728</a:t>
+                        <a:t>149</a:t>
                       </a:r>
                       <a:endParaRPr lang="en-US" altLang="ko-KR" sz="700" b="0" i="0" u="none" strike="noStrike" kern="1200" dirty="0">
                         <a:solidFill>
@@ -14427,7 +14427,7 @@
                           <a:ea typeface="대명체 보통" panose="020B0600000101010101" pitchFamily="50" charset="-127"/>
                           <a:cs typeface="+mn-cs"/>
                         </a:rPr>
-                        <a:t>105%</a:t>
+                        <a:t>102%</a:t>
                       </a:r>
                     </a:p>
                   </a:txBody>
@@ -14490,7 +14490,7 @@
                           <a:ea typeface="대명체 보통" panose="020B0600000101010101" pitchFamily="50" charset="-127"/>
                           <a:cs typeface="+mn-cs"/>
                         </a:rPr>
-                        <a:t>12,885</a:t>
+                        <a:t>3,397</a:t>
                       </a:r>
                     </a:p>
                   </a:txBody>
@@ -14608,7 +14608,7 @@
                           <a:ea typeface="대명체 보통" panose="020B0600000101010101" pitchFamily="50" charset="-127"/>
                           <a:cs typeface="+mn-cs"/>
                         </a:rPr>
-                        <a:t>2,446</a:t>
+                        <a:t>4,774</a:t>
                       </a:r>
                     </a:p>
                   </a:txBody>
@@ -14671,7 +14671,7 @@
                           <a:ea typeface="대명체 보통" panose="020B0600000101010101" pitchFamily="50" charset="-127"/>
                           <a:cs typeface="+mn-cs"/>
                         </a:rPr>
-                        <a:t>19%</a:t>
+                        <a:t>141%</a:t>
                       </a:r>
                     </a:p>
                   </a:txBody>
@@ -14786,7 +14786,7 @@
                           <a:ea typeface="대명체 보통" panose="020B0600000101010101" pitchFamily="50" charset="-127"/>
                           <a:cs typeface="+mn-cs"/>
                         </a:rPr>
-                        <a:t>72,351</a:t>
+                        <a:t>80,374</a:t>
                       </a:r>
                     </a:p>
                   </a:txBody>
@@ -14900,7 +14900,7 @@
                           <a:ea typeface="대명체 보통" panose="020B0600000101010101" pitchFamily="50" charset="-127"/>
                           <a:cs typeface="+mn-cs"/>
                         </a:rPr>
-                        <a:t>83,054</a:t>
+                        <a:t>91,225</a:t>
                       </a:r>
                     </a:p>
                   </a:txBody>
@@ -15018,7 +15018,7 @@
                           <a:ea typeface="대명체 보통" panose="020B0600000101010101" pitchFamily="50" charset="-127"/>
                           <a:cs typeface="+mn-cs"/>
                         </a:rPr>
-                        <a:t>10,703</a:t>
+                        <a:t>10,851</a:t>
                       </a:r>
                     </a:p>
                   </a:txBody>
@@ -15081,7 +15081,7 @@
                           <a:ea typeface="대명체 보통" panose="020B0600000101010101" pitchFamily="50" charset="-127"/>
                           <a:cs typeface="+mn-cs"/>
                         </a:rPr>
-                        <a:t>115%</a:t>
+                        <a:t>114%</a:t>
                       </a:r>
                     </a:p>
                   </a:txBody>
@@ -15144,7 +15144,7 @@
                           <a:ea typeface="대명체 보통" panose="020B0600000101010101" pitchFamily="50" charset="-127"/>
                           <a:cs typeface="+mn-cs"/>
                         </a:rPr>
-                        <a:t>58,458</a:t>
+                        <a:t>61,855</a:t>
                       </a:r>
                     </a:p>
                   </a:txBody>
@@ -15262,7 +15262,7 @@
                           <a:ea typeface="대명체 보통" panose="020B0600000101010101" pitchFamily="50" charset="-127"/>
                           <a:cs typeface="+mn-cs"/>
                         </a:rPr>
-                        <a:t>24,596</a:t>
+                        <a:t>29,370</a:t>
                       </a:r>
                     </a:p>
                   </a:txBody>
@@ -15325,7 +15325,7 @@
                           <a:ea typeface="대명체 보통" panose="020B0600000101010101" pitchFamily="50" charset="-127"/>
                           <a:cs typeface="+mn-cs"/>
                         </a:rPr>
-                        <a:t>42%</a:t>
+                        <a:t>47%</a:t>
                       </a:r>
                     </a:p>
                   </a:txBody>
@@ -15533,7 +15533,7 @@
                           <a:ea typeface="대명체 보통" panose="020B0600000101010101" pitchFamily="50" charset="-127"/>
                           <a:cs typeface="+mn-cs"/>
                         </a:rPr>
-                        <a:t>8,857</a:t>
+                        <a:t>5,681</a:t>
                       </a:r>
                     </a:p>
                   </a:txBody>
@@ -15643,7 +15643,7 @@
                           <a:ea typeface="대명체 보통" panose="020B0600000101010101" pitchFamily="50" charset="-127"/>
                           <a:cs typeface="+mn-cs"/>
                         </a:rPr>
-                        <a:t>9,859</a:t>
+                        <a:t>6,264</a:t>
                       </a:r>
                     </a:p>
                   </a:txBody>
@@ -15753,7 +15753,7 @@
                           <a:ea typeface="대명체 보통" panose="020B0600000101010101" pitchFamily="50" charset="-127"/>
                           <a:cs typeface="+mn-cs"/>
                         </a:rPr>
-                        <a:t>1,002</a:t>
+                        <a:t>583</a:t>
                       </a:r>
                       <a:endParaRPr lang="en-US" altLang="ko-KR" sz="700" b="0" i="0" u="none" strike="noStrike" kern="1200" dirty="0">
                         <a:solidFill>
@@ -15821,7 +15821,7 @@
                           <a:ea typeface="대명체 보통" panose="020B0600000101010101" pitchFamily="50" charset="-127"/>
                           <a:cs typeface="+mn-cs"/>
                         </a:rPr>
-                        <a:t>111%</a:t>
+                        <a:t>110%</a:t>
                       </a:r>
                     </a:p>
                   </a:txBody>
@@ -15880,7 +15880,7 @@
                           <a:ea typeface="대명체 보통" panose="020B0600000101010101" pitchFamily="50" charset="-127"/>
                           <a:cs typeface="+mn-cs"/>
                         </a:rPr>
-                        <a:t>7,694</a:t>
+                        <a:t>2,353</a:t>
                       </a:r>
                     </a:p>
                   </a:txBody>
@@ -15990,7 +15990,7 @@
                           <a:ea typeface="대명체 보통" panose="020B0600000101010101" pitchFamily="50" charset="-127"/>
                           <a:cs typeface="+mn-cs"/>
                         </a:rPr>
-                        <a:t>2,165</a:t>
+                        <a:t>3,911</a:t>
                       </a:r>
                     </a:p>
                   </a:txBody>
@@ -16049,7 +16049,7 @@
                           <a:ea typeface="대명체 보통" panose="020B0600000101010101" pitchFamily="50" charset="-127"/>
                           <a:cs typeface="+mn-cs"/>
                         </a:rPr>
-                        <a:t>28%</a:t>
+                        <a:t>166%</a:t>
                       </a:r>
                     </a:p>
                   </a:txBody>
@@ -16160,7 +16160,7 @@
                           <a:ea typeface="대명체 보통" panose="020B0600000101010101" pitchFamily="50" charset="-127"/>
                           <a:cs typeface="+mn-cs"/>
                         </a:rPr>
-                        <a:t>49,103</a:t>
+                        <a:t>54,784</a:t>
                       </a:r>
                     </a:p>
                   </a:txBody>
@@ -16266,7 +16266,7 @@
                           <a:ea typeface="대명체 보통" panose="020B0600000101010101" pitchFamily="50" charset="-127"/>
                           <a:cs typeface="+mn-cs"/>
                         </a:rPr>
-                        <a:t>53,953</a:t>
+                        <a:t>60,218</a:t>
                       </a:r>
                     </a:p>
                   </a:txBody>
@@ -16376,7 +16376,7 @@
                           <a:ea typeface="대명체 보통" panose="020B0600000101010101" pitchFamily="50" charset="-127"/>
                           <a:cs typeface="+mn-cs"/>
                         </a:rPr>
-                        <a:t>4,849</a:t>
+                        <a:t>5,434</a:t>
                       </a:r>
                     </a:p>
                   </a:txBody>
@@ -16494,7 +16494,7 @@
                           <a:ea typeface="대명체 보통" panose="020B0600000101010101" pitchFamily="50" charset="-127"/>
                           <a:cs typeface="+mn-cs"/>
                         </a:rPr>
-                        <a:t>40,447</a:t>
+                        <a:t>42,800</a:t>
                       </a:r>
                     </a:p>
                   </a:txBody>
@@ -16604,7 +16604,7 @@
                           <a:ea typeface="대명체 보통" panose="020B0600000101010101" pitchFamily="50" charset="-127"/>
                           <a:cs typeface="+mn-cs"/>
                         </a:rPr>
-                        <a:t>13,506</a:t>
+                        <a:t>17,418</a:t>
                       </a:r>
                     </a:p>
                   </a:txBody>
@@ -16663,7 +16663,7 @@
                           <a:ea typeface="대명체 보통" panose="020B0600000101010101" pitchFamily="50" charset="-127"/>
                           <a:cs typeface="+mn-cs"/>
                         </a:rPr>
-                        <a:t>33%</a:t>
+                        <a:t>41%</a:t>
                       </a:r>
                     </a:p>
                   </a:txBody>
@@ -16872,7 +16872,7 @@
                           <a:ea typeface="대명체 보통" panose="020B0600000101010101" pitchFamily="50" charset="-127"/>
                           <a:cs typeface="+mn-cs"/>
                         </a:rPr>
-                        <a:t>399</a:t>
+                        <a:t>403</a:t>
                       </a:r>
                       <a:endParaRPr lang="en-US" altLang="ko-KR" sz="700" b="0" i="0" u="none" strike="noStrike" kern="1200" dirty="0">
                         <a:solidFill>
@@ -16999,7 +16999,7 @@
                           <a:ea typeface="대명체 보통" panose="020B0600000101010101" pitchFamily="50" charset="-127"/>
                           <a:cs typeface="+mn-cs"/>
                         </a:rPr>
-                        <a:t>510</a:t>
+                        <a:t>601</a:t>
                       </a:r>
                       <a:endParaRPr lang="en-US" altLang="ko-KR" sz="700" b="0" i="0" u="none" strike="noStrike" kern="1200" dirty="0">
                         <a:solidFill>
@@ -17126,7 +17126,7 @@
                           <a:ea typeface="대명체 보통" panose="020B0600000101010101" pitchFamily="50" charset="-127"/>
                           <a:cs typeface="+mn-cs"/>
                         </a:rPr>
-                        <a:t>112</a:t>
+                        <a:t>199</a:t>
                       </a:r>
                       <a:endParaRPr lang="en-US" altLang="ko-KR" sz="700" b="0" i="0" u="none" strike="noStrike" kern="1200" dirty="0">
                         <a:solidFill>
@@ -17198,7 +17198,7 @@
                           <a:ea typeface="대명체 보통" panose="020B0600000101010101" pitchFamily="50" charset="-127"/>
                           <a:cs typeface="+mn-cs"/>
                         </a:rPr>
-                        <a:t>128%</a:t>
+                        <a:t>149%</a:t>
                       </a:r>
                     </a:p>
                   </a:txBody>
@@ -17261,7 +17261,7 @@
                           <a:ea typeface="대명체 보통" panose="020B0600000101010101" pitchFamily="50" charset="-127"/>
                           <a:cs typeface="+mn-cs"/>
                         </a:rPr>
-                        <a:t>386</a:t>
+                        <a:t>231</a:t>
                       </a:r>
                       <a:endParaRPr lang="en-US" altLang="ko-KR" sz="700" b="0" i="0" u="none" strike="noStrike" kern="1200" dirty="0">
                         <a:solidFill>
@@ -17388,7 +17388,7 @@
                           <a:ea typeface="대명체 보통" panose="020B0600000101010101" pitchFamily="50" charset="-127"/>
                           <a:cs typeface="+mn-cs"/>
                         </a:rPr>
-                        <a:t>124</a:t>
+                        <a:t>371</a:t>
                       </a:r>
                     </a:p>
                   </a:txBody>
@@ -17451,7 +17451,7 @@
                           <a:ea typeface="대명체 보통" panose="020B0600000101010101" pitchFamily="50" charset="-127"/>
                           <a:cs typeface="+mn-cs"/>
                         </a:rPr>
-                        <a:t>32%</a:t>
+                        <a:t>161%</a:t>
                       </a:r>
                     </a:p>
                   </a:txBody>
@@ -17566,7 +17566,7 @@
                           <a:ea typeface="대명체 보통" panose="020B0600000101010101" pitchFamily="50" charset="-127"/>
                           <a:cs typeface="+mn-cs"/>
                         </a:rPr>
-                        <a:t>3,467</a:t>
+                        <a:t>3,870</a:t>
                       </a:r>
                     </a:p>
                   </a:txBody>
@@ -17680,7 +17680,7 @@
                           <a:ea typeface="대명체 보통" panose="020B0600000101010101" pitchFamily="50" charset="-127"/>
                           <a:cs typeface="+mn-cs"/>
                         </a:rPr>
-                        <a:t>5,164</a:t>
+                        <a:t>5,764</a:t>
                       </a:r>
                     </a:p>
                   </a:txBody>
@@ -17798,7 +17798,7 @@
                           <a:ea typeface="대명체 보통" panose="020B0600000101010101" pitchFamily="50" charset="-127"/>
                           <a:cs typeface="+mn-cs"/>
                         </a:rPr>
-                        <a:t>1,697</a:t>
+                        <a:t>1,894</a:t>
                       </a:r>
                       <a:endParaRPr lang="en-US" altLang="ko-KR" sz="700" b="0" i="0" u="none" strike="noStrike" kern="1200" dirty="0">
                         <a:solidFill>
@@ -17933,7 +17933,7 @@
                           <a:ea typeface="대명체 보통" panose="020B0600000101010101" pitchFamily="50" charset="-127"/>
                           <a:cs typeface="+mn-cs"/>
                         </a:rPr>
-                        <a:t>3,225</a:t>
+                        <a:t>3,455</a:t>
                       </a:r>
                     </a:p>
                   </a:txBody>
@@ -18051,7 +18051,7 @@
                           <a:ea typeface="대명체 보통" panose="020B0600000101010101" pitchFamily="50" charset="-127"/>
                           <a:cs typeface="+mn-cs"/>
                         </a:rPr>
-                        <a:t>1,939</a:t>
+                        <a:t>2,309</a:t>
                       </a:r>
                     </a:p>
                   </a:txBody>
@@ -18114,7 +18114,7 @@
                           <a:ea typeface="대명체 보통" panose="020B0600000101010101" pitchFamily="50" charset="-127"/>
                           <a:cs typeface="+mn-cs"/>
                         </a:rPr>
-                        <a:t>60%</a:t>
+                        <a:t>67%</a:t>
                       </a:r>
                     </a:p>
                   </a:txBody>

</xml_diff>